<commit_message>
submission: name the research basis behind the method names
The package measured TRACE's CTC and BadDet's attack taxonomy without ever
citing them: the dashboard had no research section at all, and deck page 6's
"RESEARCH AND REFERENCES" table listed only receipts. Add the two repository
research documents (the 2025-26 state-of-the-art dossier and its citation
verification log) to every human-facing surface, and split the cited methods
into what this build actually runs -- with the code path that implements each
-- and what it only designs against, so the page cannot be read as a claim of
coverage. The HTML render and the PPTX reference tables also disagreed on
their row count; both now carry the same twelve.

🤖 Generated with Codebuff
Co-Authored-By: Codebuff <noreply@codebuff.com>
</commit_message>
<xml_diff>
--- a/sih-deck-v2/deck/CVIAF_SIH26228_template.pptx
+++ b/sih-deck-v2/deck/CVIAF_SIH26228_template.pptx
@@ -9833,7 +9833,7 @@
                 <a:gridCol w="5728716"/>
                 <a:gridCol w="5728716"/>
               </a:tblGrid>
-              <a:tr h="374072">
+              <a:tr h="316523">
                 <a:tc>
                   <a:txBody>
                     <a:bodyPr/>
@@ -9865,7 +9865,7 @@
                   <a:tcPr/>
                 </a:tc>
               </a:tr>
-              <a:tr h="374072">
+              <a:tr h="316523">
                 <a:tc>
                   <a:txBody>
                     <a:bodyPr/>
@@ -9900,7 +9900,7 @@
                   <a:tcPr/>
                 </a:tc>
               </a:tr>
-              <a:tr h="374072">
+              <a:tr h="316523">
                 <a:tc>
                   <a:txBody>
                     <a:bodyPr/>
@@ -9935,7 +9935,77 @@
                   <a:tcPr/>
                 </a:tc>
               </a:tr>
-              <a:tr h="374072">
+              <a:tr h="316523">
+                <a:tc>
+                  <a:txBody>
+                    <a:bodyPr/>
+                    <a:lstStyle/>
+                    <a:p>
+                      <a:pPr>
+                        <a:defRPr sz="850"/>
+                      </a:pPr>
+                      <a:r>
+                        <a:t>Research basis — 2025–26 state of the art</a:t>
+                      </a:r>
+                    </a:p>
+                  </a:txBody>
+                  <a:tcPr/>
+                </a:tc>
+                <a:tc>
+                  <a:txBody>
+                    <a:bodyPr wrap="square"/>
+                    <a:lstStyle/>
+                    <a:p>
+                      <a:r>
+                        <a:rPr sz="850">
+                          <a:solidFill>
+                            <a:srgbClr val="0070C0"/>
+                          </a:solidFill>
+                          <a:hlinkClick r:id="rId6"/>
+                        </a:rPr>
+                        <a:t>CV_INTEGRITY_ASSURANCE_2026.md — per-capability SOTA, the gap, and the module action list</a:t>
+                      </a:r>
+                    </a:p>
+                  </a:txBody>
+                  <a:tcPr/>
+                </a:tc>
+              </a:tr>
+              <a:tr h="316523">
+                <a:tc>
+                  <a:txBody>
+                    <a:bodyPr/>
+                    <a:lstStyle/>
+                    <a:p>
+                      <a:pPr>
+                        <a:defRPr sz="850"/>
+                      </a:pPr>
+                      <a:r>
+                        <a:t>Research verification log</a:t>
+                      </a:r>
+                    </a:p>
+                  </a:txBody>
+                  <a:tcPr/>
+                </a:tc>
+                <a:tc>
+                  <a:txBody>
+                    <a:bodyPr wrap="square"/>
+                    <a:lstStyle/>
+                    <a:p>
+                      <a:r>
+                        <a:rPr sz="850">
+                          <a:solidFill>
+                            <a:srgbClr val="0070C0"/>
+                          </a:solidFill>
+                          <a:hlinkClick r:id="rId7"/>
+                        </a:rPr>
+                        <a:t>RESEARCH_CHECKPOINT_26228.md — what was verified against which primary page, and what was dropped</a:t>
+                      </a:r>
+                    </a:p>
+                  </a:txBody>
+                  <a:tcPr/>
+                </a:tc>
+              </a:tr>
+              <a:tr h="316523">
                 <a:tc>
                   <a:txBody>
                     <a:bodyPr/>
@@ -9961,7 +10031,7 @@
                           <a:solidFill>
                             <a:srgbClr val="0070C0"/>
                           </a:solidFill>
-                          <a:hlinkClick r:id="rId6"/>
+                          <a:hlinkClick r:id="rId8"/>
                         </a:rPr>
                         <a:t>runs/mvp/comparison.json — model, data and provenance axes</a:t>
                       </a:r>
@@ -9970,7 +10040,7 @@
                   <a:tcPr/>
                 </a:tc>
               </a:tr>
-              <a:tr h="374072">
+              <a:tr h="316523">
                 <a:tc>
                   <a:txBody>
                     <a:bodyPr/>
@@ -9996,7 +10066,7 @@
                           <a:solidFill>
                             <a:srgbClr val="0070C0"/>
                           </a:solidFill>
-                          <a:hlinkClick r:id="rId7"/>
+                          <a:hlinkClick r:id="rId9"/>
                         </a:rPr>
                         <a:t>runs/merged_fpr_tpr_report.json — 56,627 models</a:t>
                       </a:r>
@@ -10005,7 +10075,7 @@
                   <a:tcPr/>
                 </a:tc>
               </a:tr>
-              <a:tr h="374072">
+              <a:tr h="316523">
                 <a:tc>
                   <a:txBody>
                     <a:bodyPr/>
@@ -10031,7 +10101,7 @@
                           <a:solidFill>
                             <a:srgbClr val="0070C0"/>
                           </a:solidFill>
-                          <a:hlinkClick r:id="rId8"/>
+                          <a:hlinkClick r:id="rId10"/>
                         </a:rPr>
                         <a:t>runs/fleet_fpr_ledger_report.json — 7,503 models, 3,751 held-out</a:t>
                       </a:r>
@@ -10040,7 +10110,7 @@
                   <a:tcPr/>
                 </a:tc>
               </a:tr>
-              <a:tr h="374072">
+              <a:tr h="316523">
                 <a:tc>
                   <a:txBody>
                     <a:bodyPr/>
@@ -10066,7 +10136,7 @@
                           <a:solidFill>
                             <a:srgbClr val="0070C0"/>
                           </a:solidFill>
-                          <a:hlinkClick r:id="rId9"/>
+                          <a:hlinkClick r:id="rId11"/>
                         </a:rPr>
                         <a:t>runs/tpr_ladder_at_frozen.json — 1,188 built / 1,055 scored</a:t>
                       </a:r>
@@ -10075,7 +10145,7 @@
                   <a:tcPr/>
                 </a:tc>
               </a:tr>
-              <a:tr h="374072">
+              <a:tr h="316523">
                 <a:tc>
                   <a:txBody>
                     <a:bodyPr/>
@@ -10101,7 +10171,7 @@
                           <a:solidFill>
                             <a:srgbClr val="0070C0"/>
                           </a:solidFill>
-                          <a:hlinkClick r:id="rId10"/>
+                          <a:hlinkClick r:id="rId12"/>
                         </a:rPr>
                         <a:t>runs/coverage.json · docs/COVERAGE_STATEMENT.md · docs/PS26228_ALIGNMENT_MATRIX.md</a:t>
                       </a:r>
@@ -10110,7 +10180,7 @@
                   <a:tcPr/>
                 </a:tc>
               </a:tr>
-              <a:tr h="374072">
+              <a:tr h="316523">
                 <a:tc>
                   <a:txBody>
                     <a:bodyPr/>
@@ -10136,7 +10206,7 @@
                           <a:solidFill>
                             <a:srgbClr val="0070C0"/>
                           </a:solidFill>
-                          <a:hlinkClick r:id="rId11"/>
+                          <a:hlinkClick r:id="rId13"/>
                         </a:rPr>
                         <a:t>runs/assurance/oda_s5/assurance_report.json — schema-valid, 17 findings</a:t>
                       </a:r>
@@ -10145,7 +10215,7 @@
                   <a:tcPr/>
                 </a:tc>
               </a:tr>
-              <a:tr h="374072">
+              <a:tr h="316523">
                 <a:tc>
                   <a:txBody>
                     <a:bodyPr/>
@@ -10171,7 +10241,7 @@
                           <a:solidFill>
                             <a:srgbClr val="0070C0"/>
                           </a:solidFill>
-                          <a:hlinkClick r:id="rId12"/>
+                          <a:hlinkClick r:id="rId14"/>
                         </a:rPr>
                         <a:t>docs/MODEL_INVENTORY.md — where every model came from</a:t>
                       </a:r>
@@ -10180,7 +10250,7 @@
                   <a:tcPr/>
                 </a:tc>
               </a:tr>
-              <a:tr h="374080">
+              <a:tr h="316524">
                 <a:tc>
                   <a:txBody>
                     <a:bodyPr/>
@@ -10206,7 +10276,7 @@
                           <a:solidFill>
                             <a:srgbClr val="0070C0"/>
                           </a:solidFill>
-                          <a:hlinkClick r:id="rId13"/>
+                          <a:hlinkClick r:id="rId15"/>
                         </a:rPr>
                         <a:t>docs/REPRODUCE.md — no network, bundle install</a:t>
                       </a:r>
@@ -10228,7 +10298,7 @@
         <p:spPr>
           <a:xfrm>
             <a:off x="384048" y="5760720"/>
-            <a:ext cx="11457432" cy="530352"/>
+            <a:ext cx="11457432" cy="566928"/>
           </a:xfrm>
           <a:prstGeom prst="rect">
             <a:avLst/>
@@ -10240,6 +10310,24 @@
             <a:spAutoFit/>
           </a:bodyPr>
           <a:lstStyle/>
+          <a:p>
+            <a:pPr>
+              <a:lnSpc>
+                <a:spcPct val="100000"/>
+              </a:lnSpc>
+              <a:spcAft>
+                <a:spcPts val="350"/>
+              </a:spcAft>
+              <a:defRPr sz="750" b="0">
+                <a:solidFill>
+                  <a:srgbClr val="8A9098"/>
+                </a:solidFill>
+              </a:defRPr>
+            </a:pPr>
+            <a:r>
+              <a:t>Signal names are published methods: CTC and FTC are TRACE (CVPR 2025, arXiv 2503.15293), and the OGA / RMA / GMA / ODA attack labels are BadDet. This engine reimplements those mechanisms at MVP scale — the published numbers stay with their authors and are not quoted here.</a:t>
+            </a:r>
+          </a:p>
           <a:p>
             <a:pPr>
               <a:lnSpc>

</xml_diff>